<commit_message>
docs: add live chat screenshot to client deck
</commit_message>
<xml_diff>
--- a/artifacts/shenzhen-sci-tech-platform-client-intro.pptx
+++ b/artifacts/shenzhen-sci-tech-platform-client-intro.pptx
@@ -5755,7 +5755,7 @@
       </p:sp>
       <p:pic>
         <p:nvPicPr>
-          <p:cNvPr id="65" name="Picture 64" descr="baseline-professors-list.png"/>
+          <p:cNvPr id="65" name="Picture 64" descr="chat-live-card.png"/>
           <p:cNvPicPr>
             <a:picLocks noChangeAspect="1"/>
           </p:cNvPicPr>
@@ -5859,7 +5859,7 @@
                 </a:solidFill>
                 <a:latin typeface="Noto Sans CJK SC"/>
               </a:rPr>
-              <a:t>教授数据资产 · 条件筛选</a:t>
+              <a:t>真实对话 · 流式检索回答</a:t>
             </a:r>
           </a:p>
         </p:txBody>

</xml_diff>